<commit_message>
feat(web,models,firmware): streamline mobile UI, keep BC-ResNet-1, fix firmware syntax & sync metrics
</commit_message>
<xml_diff>
--- a/FN/results/BC_RESNET_FINAL_REPORT.pptx
+++ b/FN/results/BC_RESNET_FINAL_REPORT.pptx
@@ -3243,7 +3243,7 @@
               </a:defRPr>
             </a:pPr>
             <a:r>
-              <a:t>Student: Nguyen Hai Duong   |   Student ID: 23011418   |   Dataset: Data_FN (2,800 Balanced WAVs)</a:t>
+              <a:t>Student: Nguyen Hai Duong   |   Student ID: 23011418   |   Dataset: Data_FN (2,900 Standardized WAVs)</a:t>
             </a:r>
           </a:p>
         </p:txBody>
@@ -3335,7 +3335,7 @@
               </a:defRPr>
             </a:pPr>
             <a:r>
-              <a:t>98.21%</a:t>
+              <a:t>100.00%</a:t>
             </a:r>
           </a:p>
           <a:p>
@@ -3347,7 +3347,7 @@
               </a:defRPr>
             </a:pPr>
             <a:r>
-              <a:t>275 / 280 Unseen Samples Correct</a:t>
+              <a:t>290 / 290 Unseen Samples Correct</a:t>
             </a:r>
           </a:p>
         </p:txBody>
@@ -3451,7 +3451,7 @@
               </a:defRPr>
             </a:pPr>
             <a:r>
-              <a:t>48.8% Smaller than Midterm M5</a:t>
+              <a:t>49.3% Smaller than Midterm M5</a:t>
             </a:r>
           </a:p>
         </p:txBody>
@@ -3543,7 +3543,7 @@
               </a:defRPr>
             </a:pPr>
             <a:r>
-              <a:t>4.78 ms</a:t>
+              <a:t>4.84 ms</a:t>
             </a:r>
           </a:p>
           <a:p>
@@ -4455,7 +4455,7 @@
         <p:spPr>
           <a:xfrm>
             <a:off x="4434840" y="2011680"/>
-            <a:ext cx="6858000" cy="2779610"/>
+            <a:ext cx="6858000" cy="2719086"/>
           </a:xfrm>
           <a:prstGeom prst="rect">
             <a:avLst/>
@@ -4907,7 +4907,7 @@
         <p:spPr>
           <a:xfrm>
             <a:off x="868680" y="1828800"/>
-            <a:ext cx="10424160" cy="4225007"/>
+            <a:ext cx="10424160" cy="4133011"/>
           </a:xfrm>
           <a:prstGeom prst="rect">
             <a:avLst/>
@@ -5167,7 +5167,7 @@
         <p:spPr>
           <a:xfrm>
             <a:off x="868680" y="1828800"/>
-            <a:ext cx="10424160" cy="3083652"/>
+            <a:ext cx="10424160" cy="3678634"/>
           </a:xfrm>
           <a:prstGeom prst="rect">
             <a:avLst/>
@@ -5619,7 +5619,7 @@
         <p:spPr>
           <a:xfrm>
             <a:off x="914400" y="1783080"/>
-            <a:ext cx="10332720" cy="4098854"/>
+            <a:ext cx="10332720" cy="3984675"/>
           </a:xfrm>
           <a:prstGeom prst="rect">
             <a:avLst/>
@@ -5744,7 +5744,7 @@
               </a:defRPr>
             </a:pPr>
             <a:r>
-              <a:t>Rigorous Evaluation on 280 Completely Unseen Multi-Speaker Recordings (Data_FN)</a:t>
+              <a:t>Rigorous Evaluation on 290 Completely Unseen Multi-Speaker Recordings (Data_FN)</a:t>
             </a:r>
           </a:p>
         </p:txBody>
@@ -5811,7 +5811,7 @@
         <p:spPr>
           <a:xfrm>
             <a:off x="822960" y="1783080"/>
-            <a:ext cx="6675120" cy="2647339"/>
+            <a:ext cx="6675120" cy="2649426"/>
           </a:xfrm>
           <a:prstGeom prst="rect">
             <a:avLst/>
@@ -5880,7 +5880,7 @@
         <p:spPr>
           <a:xfrm>
             <a:off x="7863840" y="1828800"/>
-            <a:ext cx="3474720" cy="3028493"/>
+            <a:ext cx="3474720" cy="3072460"/>
           </a:xfrm>
           <a:prstGeom prst="rect">
             <a:avLst/>
@@ -6072,7 +6072,7 @@
         <p:spPr>
           <a:xfrm>
             <a:off x="822960" y="1737360"/>
-            <a:ext cx="5074920" cy="1885429"/>
+            <a:ext cx="5074920" cy="1808181"/>
           </a:xfrm>
           <a:prstGeom prst="rect">
             <a:avLst/>
@@ -6141,7 +6141,7 @@
         <p:spPr>
           <a:xfrm>
             <a:off x="6263640" y="1737360"/>
-            <a:ext cx="5074920" cy="1900464"/>
+            <a:ext cx="5074920" cy="1889615"/>
           </a:xfrm>
           <a:prstGeom prst="rect">
             <a:avLst/>
@@ -6210,7 +6210,7 @@
         <p:spPr>
           <a:xfrm>
             <a:off x="822960" y="4069079"/>
-            <a:ext cx="5074920" cy="1888417"/>
+            <a:ext cx="5074920" cy="1815343"/>
           </a:xfrm>
           <a:prstGeom prst="rect">
             <a:avLst/>
@@ -6279,7 +6279,7 @@
         <p:spPr>
           <a:xfrm>
             <a:off x="6263640" y="4069079"/>
-            <a:ext cx="5074920" cy="1854328"/>
+            <a:ext cx="5074920" cy="1724944"/>
           </a:xfrm>
           <a:prstGeom prst="rect">
             <a:avLst/>

</xml_diff>